<commit_message>
big update bluepring v0.2
</commit_message>
<xml_diff>
--- a/backend/data/templates/education_basic.pptx
+++ b/backend/data/templates/education_basic.pptx
@@ -4951,6 +4951,30 @@
           </a:p>
         </p:txBody>
       </p:sp>
+      <p:sp>
+        <p:nvSpPr>
+          <p:cNvPr id="100" name="Picture Placeholder 10"/>
+          <p:cNvSpPr>
+            <a:spLocks noGrp="1"/>
+          </p:cNvSpPr>
+          <p:nvPr>
+            <p:ph type="pic" idx="10"/>
+          </p:nvPr>
+        </p:nvSpPr>
+        <p:spPr>
+          <a:xfrm>
+            <a:off x="6400800" y="1371600"/>
+            <a:ext cx="4572000" cy="4114800"/>
+          </a:xfrm>
+        </p:spPr>
+        <p:txBody>
+          <a:bodyPr/>
+          <a:lstStyle/>
+          <a:p>
+            <a:endParaRPr lang="en-US"/>
+          </a:p>
+        </p:txBody>
+      </p:sp>
     </p:spTree>
   </p:cSld>
 </p:sldLayout>
@@ -20967,6 +20991,30 @@
               <a:rPr lang="zh-TW"/>
               <a:t/>
             </a:r>
+          </a:p>
+        </p:txBody>
+      </p:sp>
+      <p:sp>
+        <p:nvSpPr>
+          <p:cNvPr id="100" name="Picture Placeholder 10"/>
+          <p:cNvSpPr>
+            <a:spLocks noGrp="1"/>
+          </p:cNvSpPr>
+          <p:nvPr>
+            <p:ph type="pic" idx="10"/>
+          </p:nvPr>
+        </p:nvSpPr>
+        <p:spPr>
+          <a:xfrm>
+            <a:off x="6400800" y="1371600"/>
+            <a:ext cx="4572000" cy="4114800"/>
+          </a:xfrm>
+        </p:spPr>
+        <p:txBody>
+          <a:bodyPr/>
+          <a:lstStyle/>
+          <a:p>
+            <a:endParaRPr lang="en-US"/>
           </a:p>
         </p:txBody>
       </p:sp>

</xml_diff>